<commit_message>
Add CI screenshots to docs; build UI documentation and final report
- Real simulator screenshots from the UI tests and the visionOS simulator
- Fruit category uses basket symbol instead of the Apple logo; papaya emoji
- Upload screenshots as a separate small CI artifact

Co-Authored-By: Claude Opus 5.5 <noreply@anthropic.com>
</commit_message>
<xml_diff>
--- a/docs/FreshKeep_Spatial_Pitch_IT21244384.pptx
+++ b/docs/FreshKeep_Spatial_Pitch_IT21244384.pptx
@@ -119,43 +119,43 @@
   <p:extLst>
     <p:ext uri="{521415D9-36F7-43E2-AB2F-B90AF26B5E84}">
       <p14:sectionLst xmlns:p14="http://schemas.microsoft.com/office/powerpoint/2010/main">
-        <p14:section name="Opening" id="{f03cb319-2aa3-f5a2-e2d6-5e2e0022b974}">
+        <p14:section name="Opening" id="{0d8d98ca-a981-49ab-403c-12683d1513df}">
           <p14:sldIdLst>
             <p14:sldId id="256"/>
           </p14:sldIdLst>
         </p14:section>
-        <p14:section name="Problem" id="{d0b54957-5001-31ae-1359-7a7ce51dc294}">
+        <p14:section name="Problem" id="{832bafff-de3c-33b5-1f47-ac5922cd019e}">
           <p14:sldIdLst>
             <p14:sldId id="257"/>
             <p14:sldId id="258"/>
           </p14:sldIdLst>
         </p14:section>
-        <p14:section name="Solution" id="{457e0011-8a0a-4854-4e62-9dd99fc99fc6}">
+        <p14:section name="Solution" id="{e624810f-990c-ae6f-f444-d182882b60f2}">
           <p14:sldIdLst>
             <p14:sldId id="259"/>
             <p14:sldId id="260"/>
             <p14:sldId id="261"/>
           </p14:sldIdLst>
         </p14:section>
-        <p14:section name="Market" id="{d405a2a3-8cc1-2b06-07f2-d366ca9e05e2}">
+        <p14:section name="Market" id="{9b59d1f1-d267-1612-c760-d9ca19074e1f}">
           <p14:sldIdLst>
             <p14:sldId id="262"/>
             <p14:sldId id="263"/>
           </p14:sldIdLst>
         </p14:section>
-        <p14:section name="Business" id="{92f56469-1e72-fe16-8af5-1d3a87d3a8ba}">
+        <p14:section name="Business" id="{d870e9ff-25d9-4772-d309-2e7b44d1796d}">
           <p14:sldIdLst>
             <p14:sldId id="264"/>
             <p14:sldId id="265"/>
           </p14:sldIdLst>
         </p14:section>
-        <p14:section name="Technology" id="{b91a8a8d-465c-e7ab-74d6-67f7ae5daa92}">
+        <p14:section name="Technology" id="{3ea45c97-1a7c-f740-6a74-2a1ccb40006c}">
           <p14:sldIdLst>
             <p14:sldId id="266"/>
             <p14:sldId id="267"/>
           </p14:sldIdLst>
         </p14:section>
-        <p14:section name="Close" id="{57250cce-893f-3c6f-3d05-10d491cc93a6}">
+        <p14:section name="Close" id="{848f424c-c097-4992-c97a-5982b8af004b}">
           <p14:sldIdLst>
             <p14:sldId id="268"/>
           </p14:sldIdLst>
@@ -1727,7 +1727,7 @@
         <p:spPr>
           <a:xfrm>
             <a:off x="640080" y="2103120"/>
-            <a:ext cx="7498080" cy="1463040"/>
+            <a:ext cx="7863840" cy="1463040"/>
           </a:xfrm>
           <a:prstGeom prst="rect">
             <a:avLst/>
@@ -1738,9 +1738,9 @@
         <p:txBody>
           <a:bodyPr wrap="square" rtlCol="0"/>
           <a:lstStyle>
-            <a:lvl1pPr indent="0" marL="0">
-              <a:buNone/>
-              <a:defRPr lang="en-US" sz="5400" b="1" dirty="0">
+            <a:lvl1pPr algn="l" indent="0" marL="0">
+              <a:buNone/>
+              <a:defRPr lang="en-US" sz="5000" b="1" dirty="0">
                 <a:solidFill>
                   <a:schemeClr val="bg1"/>
                 </a:solidFill>
@@ -1748,10 +1748,10 @@
             </a:lvl1pPr>
           </a:lstStyle>
           <a:p>
-            <a:pPr indent="0" marL="0">
-              <a:buNone/>
-            </a:pPr>
-            <a:endParaRPr lang="en-US" sz="5400" dirty="0"/>
+            <a:pPr algn="l" indent="0" marL="0">
+              <a:buNone/>
+            </a:pPr>
+            <a:endParaRPr lang="en-US" sz="5000" dirty="0"/>
           </a:p>
         </p:txBody>
       </p:sp>
@@ -1766,7 +1766,7 @@
         <p:spPr>
           <a:xfrm>
             <a:off x="640080" y="3657600"/>
-            <a:ext cx="7498080" cy="1097280"/>
+            <a:ext cx="7863840" cy="1097280"/>
           </a:xfrm>
           <a:prstGeom prst="rect">
             <a:avLst/>
@@ -1777,7 +1777,7 @@
         <p:txBody>
           <a:bodyPr wrap="square" rtlCol="0"/>
           <a:lstStyle>
-            <a:lvl1pPr indent="0" marL="0">
+            <a:lvl1pPr algn="l" indent="0" marL="0">
               <a:buNone/>
               <a:defRPr lang="en-US" sz="2200" dirty="0">
                 <a:solidFill>
@@ -1787,7 +1787,7 @@
             </a:lvl1pPr>
           </a:lstStyle>
           <a:p>
-            <a:pPr indent="0" marL="0">
+            <a:pPr algn="l" indent="0" marL="0">
               <a:buNone/>
             </a:pPr>
             <a:endParaRPr lang="en-US" sz="2200" dirty="0"/>
@@ -2306,7 +2306,7 @@
         <p:spPr>
           <a:xfrm>
             <a:off x="640080" y="2103120"/>
-            <a:ext cx="7498080" cy="1463040"/>
+            <a:ext cx="7863840" cy="1463040"/>
           </a:xfrm>
           <a:prstGeom prst="rect">
             <a:avLst/>
@@ -2318,18 +2318,18 @@
           <a:bodyPr wrap="square" lIns="0" tIns="0" rIns="0" bIns="0" rtlCol="0" anchor="b"/>
           <a:lstStyle/>
           <a:p>
-            <a:pPr indent="0" marL="0">
-              <a:buNone/>
-            </a:pPr>
-            <a:r>
-              <a:rPr lang="en-US" sz="5400" b="1" dirty="0">
+            <a:pPr algn="l" indent="0" marL="0">
+              <a:buNone/>
+            </a:pPr>
+            <a:r>
+              <a:rPr lang="en-US" sz="5000" b="1" dirty="0">
                 <a:solidFill>
                   <a:schemeClr val="bg1"/>
                 </a:solidFill>
               </a:rPr>
               <a:t>FreshKeep Spatial</a:t>
             </a:r>
-            <a:endParaRPr lang="en-US" sz="5400" dirty="0"/>
+            <a:endParaRPr lang="en-US" sz="5000" dirty="0"/>
           </a:p>
         </p:txBody>
       </p:sp>
@@ -2344,7 +2344,7 @@
         <p:spPr>
           <a:xfrm>
             <a:off x="640080" y="3657600"/>
-            <a:ext cx="7498080" cy="1097280"/>
+            <a:ext cx="7863840" cy="1097280"/>
           </a:xfrm>
           <a:prstGeom prst="rect">
             <a:avLst/>
@@ -2356,7 +2356,7 @@
           <a:bodyPr wrap="square" lIns="0" tIns="0" rIns="0" bIns="0" rtlCol="0" anchor="t"/>
           <a:lstStyle/>
           <a:p>
-            <a:pPr indent="0" marL="0">
+            <a:pPr algn="l" indent="0" marL="0">
               <a:buNone/>
             </a:pPr>
             <a:r>
@@ -2544,7 +2544,7 @@
       </p:sp>
       <p:sp>
         <p:nvSpPr>
-          <p:cNvPr id="5" name="t-92"/>
+          <p:cNvPr id="5" name="t-91"/>
           <p:cNvSpPr txBox="1"/>
           <p:nvPr/>
         </p:nvSpPr>
@@ -2580,7 +2580,7 @@
       </p:sp>
       <p:sp>
         <p:nvSpPr>
-          <p:cNvPr id="6" name="t-93"/>
+          <p:cNvPr id="6" name="t-92"/>
           <p:cNvSpPr txBox="1"/>
           <p:nvPr/>
         </p:nvSpPr>
@@ -2616,7 +2616,7 @@
       </p:sp>
       <p:sp>
         <p:nvSpPr>
-          <p:cNvPr id="7" name="t-94"/>
+          <p:cNvPr id="7" name="t-93"/>
           <p:cNvSpPr txBox="1"/>
           <p:nvPr/>
         </p:nvSpPr>
@@ -2677,7 +2677,7 @@
       </p:sp>
       <p:sp>
         <p:nvSpPr>
-          <p:cNvPr id="9" name="t-95"/>
+          <p:cNvPr id="9" name="t-94"/>
           <p:cNvSpPr txBox="1"/>
           <p:nvPr/>
         </p:nvSpPr>
@@ -2713,7 +2713,7 @@
       </p:sp>
       <p:sp>
         <p:nvSpPr>
-          <p:cNvPr id="10" name="t-96"/>
+          <p:cNvPr id="10" name="t-95"/>
           <p:cNvSpPr txBox="1"/>
           <p:nvPr/>
         </p:nvSpPr>
@@ -2749,7 +2749,7 @@
       </p:sp>
       <p:sp>
         <p:nvSpPr>
-          <p:cNvPr id="11" name="t-97"/>
+          <p:cNvPr id="11" name="t-96"/>
           <p:cNvSpPr txBox="1"/>
           <p:nvPr/>
         </p:nvSpPr>
@@ -2810,7 +2810,7 @@
       </p:sp>
       <p:sp>
         <p:nvSpPr>
-          <p:cNvPr id="13" name="t-98"/>
+          <p:cNvPr id="13" name="t-97"/>
           <p:cNvSpPr txBox="1"/>
           <p:nvPr/>
         </p:nvSpPr>
@@ -2846,7 +2846,7 @@
       </p:sp>
       <p:sp>
         <p:nvSpPr>
-          <p:cNvPr id="14" name="t-99"/>
+          <p:cNvPr id="14" name="t-98"/>
           <p:cNvSpPr txBox="1"/>
           <p:nvPr/>
         </p:nvSpPr>
@@ -2882,7 +2882,7 @@
       </p:sp>
       <p:sp>
         <p:nvSpPr>
-          <p:cNvPr id="15" name="t-100"/>
+          <p:cNvPr id="15" name="t-99"/>
           <p:cNvSpPr txBox="1"/>
           <p:nvPr/>
         </p:nvSpPr>
@@ -2943,7 +2943,7 @@
       </p:sp>
       <p:sp>
         <p:nvSpPr>
-          <p:cNvPr id="17" name="t-101"/>
+          <p:cNvPr id="17" name="t-100"/>
           <p:cNvSpPr txBox="1"/>
           <p:nvPr/>
         </p:nvSpPr>
@@ -2979,7 +2979,7 @@
       </p:sp>
       <p:sp>
         <p:nvSpPr>
-          <p:cNvPr id="18" name="t-102"/>
+          <p:cNvPr id="18" name="t-101"/>
           <p:cNvSpPr txBox="1"/>
           <p:nvPr/>
         </p:nvSpPr>
@@ -3015,7 +3015,7 @@
       </p:sp>
       <p:sp>
         <p:nvSpPr>
-          <p:cNvPr id="19" name="t-103"/>
+          <p:cNvPr id="19" name="t-102"/>
           <p:cNvSpPr txBox="1"/>
           <p:nvPr/>
         </p:nvSpPr>
@@ -3159,7 +3159,7 @@
       </p:sp>
       <p:pic>
         <p:nvPicPr>
-          <p:cNvPr id="3" name="img-104" descr="C:\Users\srith\Projects\SE4041-FreshKeep\docs\images\architecture.png">    </p:cNvPr>
+          <p:cNvPr id="3" name="img-103" descr="C:\Users\srith\Projects\SE4041-FreshKeep\docs\images\architecture.png">    </p:cNvPr>
           <p:cNvPicPr>
             <a:picLocks noChangeAspect="1"/>
           </p:cNvPicPr>
@@ -3403,7 +3403,7 @@
       </p:sp>
       <p:sp>
         <p:nvSpPr>
-          <p:cNvPr id="3" name="card-105"/>
+          <p:cNvPr id="3" name="card-104"/>
           <p:cNvSpPr/>
           <p:nvPr/>
         </p:nvSpPr>
@@ -3430,7 +3430,7 @@
       </p:sp>
       <p:sp>
         <p:nvSpPr>
-          <p:cNvPr id="4" name="t-106"/>
+          <p:cNvPr id="4" name="t-105"/>
           <p:cNvSpPr txBox="1"/>
           <p:nvPr/>
         </p:nvSpPr>
@@ -3466,7 +3466,7 @@
       </p:sp>
       <p:sp>
         <p:nvSpPr>
-          <p:cNvPr id="5" name="t-107"/>
+          <p:cNvPr id="5" name="t-106"/>
           <p:cNvSpPr txBox="1"/>
           <p:nvPr/>
         </p:nvSpPr>
@@ -3502,7 +3502,7 @@
       </p:sp>
       <p:sp>
         <p:nvSpPr>
-          <p:cNvPr id="6" name="card-108"/>
+          <p:cNvPr id="6" name="card-107"/>
           <p:cNvSpPr/>
           <p:nvPr/>
         </p:nvSpPr>
@@ -3529,7 +3529,7 @@
       </p:sp>
       <p:sp>
         <p:nvSpPr>
-          <p:cNvPr id="7" name="t-109"/>
+          <p:cNvPr id="7" name="t-108"/>
           <p:cNvSpPr txBox="1"/>
           <p:nvPr/>
         </p:nvSpPr>
@@ -3565,7 +3565,7 @@
       </p:sp>
       <p:sp>
         <p:nvSpPr>
-          <p:cNvPr id="8" name="t-110"/>
+          <p:cNvPr id="8" name="t-109"/>
           <p:cNvSpPr txBox="1"/>
           <p:nvPr/>
         </p:nvSpPr>
@@ -3601,7 +3601,7 @@
       </p:sp>
       <p:sp>
         <p:nvSpPr>
-          <p:cNvPr id="9" name="card-111"/>
+          <p:cNvPr id="9" name="card-110"/>
           <p:cNvSpPr/>
           <p:nvPr/>
         </p:nvSpPr>
@@ -3628,7 +3628,7 @@
       </p:sp>
       <p:sp>
         <p:nvSpPr>
-          <p:cNvPr id="10" name="t-112"/>
+          <p:cNvPr id="10" name="t-111"/>
           <p:cNvSpPr txBox="1"/>
           <p:nvPr/>
         </p:nvSpPr>
@@ -3664,7 +3664,7 @@
       </p:sp>
       <p:sp>
         <p:nvSpPr>
-          <p:cNvPr id="11" name="t-113"/>
+          <p:cNvPr id="11" name="t-112"/>
           <p:cNvSpPr txBox="1"/>
           <p:nvPr/>
         </p:nvSpPr>
@@ -3700,7 +3700,7 @@
       </p:sp>
       <p:sp>
         <p:nvSpPr>
-          <p:cNvPr id="12" name="t-114"/>
+          <p:cNvPr id="12" name="t-113"/>
           <p:cNvSpPr txBox="1"/>
           <p:nvPr/>
         </p:nvSpPr>
@@ -3909,7 +3909,7 @@
         <p:spPr>
           <a:xfrm>
             <a:off x="640080" y="2103120"/>
-            <a:ext cx="7498080" cy="1463040"/>
+            <a:ext cx="7863840" cy="1463040"/>
           </a:xfrm>
           <a:prstGeom prst="rect">
             <a:avLst/>
@@ -3921,18 +3921,18 @@
           <a:bodyPr wrap="square" lIns="0" tIns="0" rIns="0" bIns="0" rtlCol="0" anchor="b"/>
           <a:lstStyle/>
           <a:p>
-            <a:pPr indent="0" marL="0">
-              <a:buNone/>
-            </a:pPr>
-            <a:r>
-              <a:rPr lang="en-US" sz="5400" b="1" dirty="0">
+            <a:pPr algn="l" indent="0" marL="0">
+              <a:buNone/>
+            </a:pPr>
+            <a:r>
+              <a:rPr lang="en-US" sz="5000" b="1" dirty="0">
                 <a:solidFill>
                   <a:schemeClr val="bg1"/>
                 </a:solidFill>
               </a:rPr>
-              <a:t>See your food. Save your food.</a:t>
-            </a:r>
-            <a:endParaRPr lang="en-US" sz="5400" dirty="0"/>
+              <a:t>See it. Save it.</a:t>
+            </a:r>
+            <a:endParaRPr lang="en-US" sz="5000" dirty="0"/>
           </a:p>
         </p:txBody>
       </p:sp>
@@ -3947,7 +3947,7 @@
         <p:spPr>
           <a:xfrm>
             <a:off x="640080" y="3657600"/>
-            <a:ext cx="7498080" cy="1097280"/>
+            <a:ext cx="7863840" cy="1097280"/>
           </a:xfrm>
           <a:prstGeom prst="rect">
             <a:avLst/>
@@ -3959,24 +3959,60 @@
           <a:bodyPr wrap="square" lIns="0" tIns="0" rIns="0" bIns="0" rtlCol="0" anchor="t"/>
           <a:lstStyle/>
           <a:p>
+            <a:pPr algn="l" indent="0" marL="0">
+              <a:buNone/>
+            </a:pPr>
+            <a:r>
+              <a:rPr lang="en-US" sz="2200" dirty="0">
+                <a:solidFill>
+                  <a:srgbClr val="C8E8D4"/>
+                </a:solidFill>
+              </a:rPr>
+              <a:t>Thank you — questions?</a:t>
+            </a:r>
+            <a:endParaRPr lang="en-US" sz="2200" dirty="0"/>
+          </a:p>
+        </p:txBody>
+      </p:sp>
+      <p:sp>
+        <p:nvSpPr>
+          <p:cNvPr id="4" name="t-114"/>
+          <p:cNvSpPr txBox="1"/>
+          <p:nvPr/>
+        </p:nvSpPr>
+        <p:spPr>
+          <a:xfrm>
+            <a:off x="640080" y="6035040"/>
+            <a:ext cx="8229600" cy="365760"/>
+          </a:xfrm>
+          <a:prstGeom prst="rect">
+            <a:avLst/>
+          </a:prstGeom>
+          <a:noFill/>
+          <a:ln/>
+        </p:spPr>
+        <p:txBody>
+          <a:bodyPr wrap="square" lIns="0" tIns="0" rIns="0" bIns="0" rtlCol="0" anchor="t"/>
+          <a:lstStyle/>
+          <a:p>
             <a:pPr indent="0" marL="0">
               <a:buNone/>
             </a:pPr>
             <a:r>
-              <a:rPr lang="en-US" sz="2200" dirty="0">
+              <a:rPr lang="en-US" sz="1400" dirty="0">
                 <a:solidFill>
                   <a:srgbClr val="C8E8D4"/>
                 </a:solidFill>
               </a:rPr>
-              <a:t>Thank you — questions?  ·  github.com/IT21244384/SE4041-FreshKeep</a:t>
-            </a:r>
-            <a:endParaRPr lang="en-US" sz="2200" dirty="0"/>
+              <a:t>github.com/IT21244384/SE4041-FreshKeep</a:t>
+            </a:r>
+            <a:endParaRPr lang="en-US" sz="1400" dirty="0"/>
           </a:p>
         </p:txBody>
       </p:sp>
       <p:pic>
         <p:nvPicPr>
-          <p:cNvPr id="4" name="img-115" descr="C:\Users\srith\Projects\SE4041-FreshKeep\docs\images\app-icon.png">    </p:cNvPr>
+          <p:cNvPr id="5" name="img-115" descr="C:\Users\srith\Projects\SE4041-FreshKeep\docs\images\app-icon.png">    </p:cNvPr>
           <p:cNvPicPr>
             <a:picLocks noChangeAspect="1"/>
           </p:cNvPicPr>
@@ -6039,33 +6075,30 @@
           </a:p>
         </p:txBody>
       </p:sp>
-      <p:sp>
-        <p:nvSpPr>
-          <p:cNvPr id="3" name="card-44"/>
-          <p:cNvSpPr/>
-          <p:nvPr/>
-        </p:nvSpPr>
-        <p:spPr>
-          <a:xfrm>
-            <a:off x="548640" y="1371600"/>
-            <a:ext cx="6949440" cy="4800600"/>
-          </a:xfrm>
-          <a:prstGeom prst="roundRect">
-            <a:avLst>
-              <a:gd name="adj" fmla="val 3429"/>
-            </a:avLst>
-          </a:prstGeom>
-          <a:solidFill>
-            <a:srgbClr val="E9EEE6"/>
-          </a:solidFill>
-          <a:ln w="12700">
-            <a:solidFill>
-              <a:srgbClr val="E9EEE6"/>
-            </a:solidFill>
-            <a:prstDash val="solid"/>
-          </a:ln>
-        </p:spPr>
-      </p:sp>
+      <p:pic>
+        <p:nvPicPr>
+          <p:cNvPr id="3" name="img-44" descr="C:\Users\srith\Projects\SE4041-FreshKeep\docs\images\visionos-window.png">    </p:cNvPr>
+          <p:cNvPicPr>
+            <a:picLocks noChangeAspect="1"/>
+          </p:cNvPicPr>
+          <p:nvPr/>
+        </p:nvPicPr>
+        <p:blipFill>
+          <a:blip r:embed="rId1"/>
+          <a:stretch>
+            <a:fillRect/>
+          </a:stretch>
+        </p:blipFill>
+        <p:spPr>
+          <a:xfrm>
+            <a:off x="548640" y="1417320"/>
+            <a:ext cx="7040880" cy="4608576"/>
+          </a:xfrm>
+          <a:prstGeom prst="rect">
+            <a:avLst/>
+          </a:prstGeom>
+        </p:spPr>
+      </p:pic>
       <p:sp>
         <p:nvSpPr>
           <p:cNvPr id="4" name="t-45"/>
@@ -6074,8 +6107,8 @@
         </p:nvSpPr>
         <p:spPr>
           <a:xfrm>
-            <a:off x="548640" y="3589020"/>
-            <a:ext cx="6949440" cy="365760"/>
+            <a:off x="7863840" y="1463040"/>
+            <a:ext cx="3840480" cy="365760"/>
           </a:xfrm>
           <a:prstGeom prst="rect">
             <a:avLst/>
@@ -6087,18 +6120,18 @@
           <a:bodyPr wrap="square" lIns="0" tIns="0" rIns="0" bIns="0" rtlCol="0" anchor="t"/>
           <a:lstStyle/>
           <a:p>
-            <a:pPr algn="ctr" indent="0" marL="0">
-              <a:buNone/>
-            </a:pPr>
-            <a:r>
-              <a:rPr lang="en-US" sz="1600" dirty="0">
-                <a:solidFill>
-                  <a:srgbClr val="5F6B64"/>
-                </a:solidFill>
-              </a:rPr>
-              <a:t>[visionos-main.png]</a:t>
-            </a:r>
-            <a:endParaRPr lang="en-US" sz="1600" dirty="0"/>
+            <a:pPr indent="0" marL="0">
+              <a:buNone/>
+            </a:pPr>
+            <a:r>
+              <a:rPr lang="en-US" sz="1800" b="1" dirty="0">
+                <a:solidFill>
+                  <a:srgbClr val="0F6B47"/>
+                </a:solidFill>
+              </a:rPr>
+              <a:t>RealityKit volume</a:t>
+            </a:r>
+            <a:endParaRPr lang="en-US" sz="1800" dirty="0"/>
           </a:p>
         </p:txBody>
       </p:sp>
@@ -6110,8 +6143,8 @@
         </p:nvSpPr>
         <p:spPr>
           <a:xfrm>
-            <a:off x="7863840" y="1463040"/>
-            <a:ext cx="3840480" cy="365760"/>
+            <a:off x="7863840" y="1828800"/>
+            <a:ext cx="3840480" cy="502920"/>
           </a:xfrm>
           <a:prstGeom prst="rect">
             <a:avLst/>
@@ -6127,14 +6160,14 @@
               <a:buNone/>
             </a:pPr>
             <a:r>
-              <a:rPr lang="en-US" sz="1800" b="1" dirty="0">
-                <a:solidFill>
-                  <a:srgbClr val="0F6B47"/>
-                </a:solidFill>
-              </a:rPr>
-              <a:t>RealityKit volume</a:t>
-            </a:r>
-            <a:endParaRPr lang="en-US" sz="1800" dirty="0"/>
+              <a:rPr lang="en-US" sz="1400" dirty="0">
+                <a:solidFill>
+                  <a:srgbClr val="5F6B64"/>
+                </a:solidFill>
+              </a:rPr>
+              <a:t>generated 3D shelves, tokens and pot — no asset files</a:t>
+            </a:r>
+            <a:endParaRPr lang="en-US" sz="1400" dirty="0"/>
           </a:p>
         </p:txBody>
       </p:sp>
@@ -6146,8 +6179,8 @@
         </p:nvSpPr>
         <p:spPr>
           <a:xfrm>
-            <a:off x="7863840" y="1828800"/>
-            <a:ext cx="3840480" cy="502920"/>
+            <a:off x="7863840" y="2395728"/>
+            <a:ext cx="3840480" cy="365760"/>
           </a:xfrm>
           <a:prstGeom prst="rect">
             <a:avLst/>
@@ -6163,14 +6196,14 @@
               <a:buNone/>
             </a:pPr>
             <a:r>
-              <a:rPr lang="en-US" sz="1400" dirty="0">
-                <a:solidFill>
-                  <a:srgbClr val="5F6B64"/>
-                </a:solidFill>
-              </a:rPr>
-              <a:t>generated 3D shelves, tokens and pot — no asset files</a:t>
-            </a:r>
-            <a:endParaRPr lang="en-US" sz="1400" dirty="0"/>
+              <a:rPr lang="en-US" sz="1800" b="1" dirty="0">
+                <a:solidFill>
+                  <a:srgbClr val="0F6B47"/>
+                </a:solidFill>
+              </a:rPr>
+              <a:t>Spatial gestures</a:t>
+            </a:r>
+            <a:endParaRPr lang="en-US" sz="1800" dirty="0"/>
           </a:p>
         </p:txBody>
       </p:sp>
@@ -6182,8 +6215,8 @@
         </p:nvSpPr>
         <p:spPr>
           <a:xfrm>
-            <a:off x="7863840" y="2395728"/>
-            <a:ext cx="3840480" cy="365760"/>
+            <a:off x="7863840" y="2761488"/>
+            <a:ext cx="3840480" cy="502920"/>
           </a:xfrm>
           <a:prstGeom prst="rect">
             <a:avLst/>
@@ -6199,14 +6232,14 @@
               <a:buNone/>
             </a:pPr>
             <a:r>
-              <a:rPr lang="en-US" sz="1800" b="1" dirty="0">
-                <a:solidFill>
-                  <a:srgbClr val="0F6B47"/>
-                </a:solidFill>
-              </a:rPr>
-              <a:t>Spatial gestures</a:t>
-            </a:r>
-            <a:endParaRPr lang="en-US" sz="1800" dirty="0"/>
+              <a:rPr lang="en-US" sz="1400" dirty="0">
+                <a:solidFill>
+                  <a:srgbClr val="5F6B64"/>
+                </a:solidFill>
+              </a:rPr>
+              <a:t>SpatialTapGesture + DragGesture targeted to entities</a:t>
+            </a:r>
+            <a:endParaRPr lang="en-US" sz="1400" dirty="0"/>
           </a:p>
         </p:txBody>
       </p:sp>
@@ -6218,8 +6251,8 @@
         </p:nvSpPr>
         <p:spPr>
           <a:xfrm>
-            <a:off x="7863840" y="2761488"/>
-            <a:ext cx="3840480" cy="502920"/>
+            <a:off x="7863840" y="3328416"/>
+            <a:ext cx="3840480" cy="365760"/>
           </a:xfrm>
           <a:prstGeom prst="rect">
             <a:avLst/>
@@ -6235,14 +6268,14 @@
               <a:buNone/>
             </a:pPr>
             <a:r>
-              <a:rPr lang="en-US" sz="1400" dirty="0">
-                <a:solidFill>
-                  <a:srgbClr val="5F6B64"/>
-                </a:solidFill>
-              </a:rPr>
-              <a:t>SpatialTapGesture + DragGesture targeted to entities</a:t>
-            </a:r>
-            <a:endParaRPr lang="en-US" sz="1400" dirty="0"/>
+              <a:rPr lang="en-US" sz="1800" b="1" dirty="0">
+                <a:solidFill>
+                  <a:srgbClr val="0F6B47"/>
+                </a:solidFill>
+              </a:rPr>
+              <a:t>Attachments</a:t>
+            </a:r>
+            <a:endParaRPr lang="en-US" sz="1800" dirty="0"/>
           </a:p>
         </p:txBody>
       </p:sp>
@@ -6254,8 +6287,8 @@
         </p:nvSpPr>
         <p:spPr>
           <a:xfrm>
-            <a:off x="7863840" y="3328416"/>
-            <a:ext cx="3840480" cy="365760"/>
+            <a:off x="7863840" y="3694176"/>
+            <a:ext cx="3840480" cy="502920"/>
           </a:xfrm>
           <a:prstGeom prst="rect">
             <a:avLst/>
@@ -6271,14 +6304,14 @@
               <a:buNone/>
             </a:pPr>
             <a:r>
-              <a:rPr lang="en-US" sz="1800" b="1" dirty="0">
-                <a:solidFill>
-                  <a:srgbClr val="0F6B47"/>
-                </a:solidFill>
-              </a:rPr>
-              <a:t>Attachments</a:t>
-            </a:r>
-            <a:endParaRPr lang="en-US" sz="1800" dirty="0"/>
+              <a:rPr lang="en-US" sz="1400" dirty="0">
+                <a:solidFill>
+                  <a:srgbClr val="5F6B64"/>
+                </a:solidFill>
+              </a:rPr>
+              <a:t>SwiftUI glass cards floating above 3D items</a:t>
+            </a:r>
+            <a:endParaRPr lang="en-US" sz="1400" dirty="0"/>
           </a:p>
         </p:txBody>
       </p:sp>
@@ -6290,8 +6323,8 @@
         </p:nvSpPr>
         <p:spPr>
           <a:xfrm>
-            <a:off x="7863840" y="3694176"/>
-            <a:ext cx="3840480" cy="502920"/>
+            <a:off x="7863840" y="4261104"/>
+            <a:ext cx="3840480" cy="365760"/>
           </a:xfrm>
           <a:prstGeom prst="rect">
             <a:avLst/>
@@ -6307,14 +6340,14 @@
               <a:buNone/>
             </a:pPr>
             <a:r>
-              <a:rPr lang="en-US" sz="1400" dirty="0">
-                <a:solidFill>
-                  <a:srgbClr val="5F6B64"/>
-                </a:solidFill>
-              </a:rPr>
-              <a:t>SwiftUI glass cards floating above 3D items</a:t>
-            </a:r>
-            <a:endParaRPr lang="en-US" sz="1400" dirty="0"/>
+              <a:rPr lang="en-US" sz="1800" b="1" dirty="0">
+                <a:solidFill>
+                  <a:srgbClr val="0F6B47"/>
+                </a:solidFill>
+              </a:rPr>
+              <a:t>Shared data</a:t>
+            </a:r>
+            <a:endParaRPr lang="en-US" sz="1800" dirty="0"/>
           </a:p>
         </p:txBody>
       </p:sp>
@@ -6326,8 +6359,8 @@
         </p:nvSpPr>
         <p:spPr>
           <a:xfrm>
-            <a:off x="7863840" y="4261104"/>
-            <a:ext cx="3840480" cy="365760"/>
+            <a:off x="7863840" y="4626864"/>
+            <a:ext cx="3840480" cy="502920"/>
           </a:xfrm>
           <a:prstGeom prst="rect">
             <a:avLst/>
@@ -6343,14 +6376,14 @@
               <a:buNone/>
             </a:pPr>
             <a:r>
-              <a:rPr lang="en-US" sz="1800" b="1" dirty="0">
-                <a:solidFill>
-                  <a:srgbClr val="0F6B47"/>
-                </a:solidFill>
-              </a:rPr>
-              <a:t>Shared data</a:t>
-            </a:r>
-            <a:endParaRPr lang="en-US" sz="1800" dirty="0"/>
+              <a:rPr lang="en-US" sz="1400" dirty="0">
+                <a:solidFill>
+                  <a:srgbClr val="5F6B64"/>
+                </a:solidFill>
+              </a:rPr>
+              <a:t>same SwiftData model + FreshKeepCore package as iOS</a:t>
+            </a:r>
+            <a:endParaRPr lang="en-US" sz="1400" dirty="0"/>
           </a:p>
         </p:txBody>
       </p:sp>
@@ -6362,42 +6395,6 @@
         </p:nvSpPr>
         <p:spPr>
           <a:xfrm>
-            <a:off x="7863840" y="4626864"/>
-            <a:ext cx="3840480" cy="502920"/>
-          </a:xfrm>
-          <a:prstGeom prst="rect">
-            <a:avLst/>
-          </a:prstGeom>
-          <a:noFill/>
-          <a:ln/>
-        </p:spPr>
-        <p:txBody>
-          <a:bodyPr wrap="square" lIns="0" tIns="0" rIns="0" bIns="0" rtlCol="0" anchor="t"/>
-          <a:lstStyle/>
-          <a:p>
-            <a:pPr indent="0" marL="0">
-              <a:buNone/>
-            </a:pPr>
-            <a:r>
-              <a:rPr lang="en-US" sz="1400" dirty="0">
-                <a:solidFill>
-                  <a:srgbClr val="5F6B64"/>
-                </a:solidFill>
-              </a:rPr>
-              <a:t>same SwiftData model + FreshKeepCore package as iOS</a:t>
-            </a:r>
-            <a:endParaRPr lang="en-US" sz="1400" dirty="0"/>
-          </a:p>
-        </p:txBody>
-      </p:sp>
-      <p:sp>
-        <p:nvSpPr>
-          <p:cNvPr id="13" name="t-54"/>
-          <p:cNvSpPr txBox="1"/>
-          <p:nvPr/>
-        </p:nvSpPr>
-        <p:spPr>
-          <a:xfrm>
             <a:off x="7863840" y="5193792"/>
             <a:ext cx="3840480" cy="365760"/>
           </a:xfrm>
@@ -6428,7 +6425,7 @@
       </p:sp>
       <p:sp>
         <p:nvSpPr>
-          <p:cNvPr id="14" name="t-55"/>
+          <p:cNvPr id="13" name="t-54"/>
           <p:cNvSpPr txBox="1"/>
           <p:nvPr/>
         </p:nvSpPr>
@@ -6572,7 +6569,7 @@
       </p:sp>
       <p:sp>
         <p:nvSpPr>
-          <p:cNvPr id="3" name="icon-bg-56"/>
+          <p:cNvPr id="3" name="icon-bg-55"/>
           <p:cNvSpPr/>
           <p:nvPr/>
         </p:nvSpPr>
@@ -6597,7 +6594,7 @@
       </p:sp>
       <p:sp>
         <p:nvSpPr>
-          <p:cNvPr id="4" name="icon-56"/>
+          <p:cNvPr id="4" name="icon-55"/>
           <p:cNvSpPr txBox="1"/>
           <p:nvPr/>
         </p:nvSpPr>
@@ -6633,7 +6630,7 @@
       </p:sp>
       <p:sp>
         <p:nvSpPr>
-          <p:cNvPr id="5" name="t-57"/>
+          <p:cNvPr id="5" name="t-56"/>
           <p:cNvSpPr txBox="1"/>
           <p:nvPr/>
         </p:nvSpPr>
@@ -6669,7 +6666,7 @@
       </p:sp>
       <p:sp>
         <p:nvSpPr>
-          <p:cNvPr id="6" name="t-58"/>
+          <p:cNvPr id="6" name="t-57"/>
           <p:cNvSpPr txBox="1"/>
           <p:nvPr/>
         </p:nvSpPr>
@@ -6705,7 +6702,7 @@
       </p:sp>
       <p:sp>
         <p:nvSpPr>
-          <p:cNvPr id="7" name="icon-bg-59"/>
+          <p:cNvPr id="7" name="icon-bg-58"/>
           <p:cNvSpPr/>
           <p:nvPr/>
         </p:nvSpPr>
@@ -6730,7 +6727,7 @@
       </p:sp>
       <p:sp>
         <p:nvSpPr>
-          <p:cNvPr id="8" name="icon-59"/>
+          <p:cNvPr id="8" name="icon-58"/>
           <p:cNvSpPr txBox="1"/>
           <p:nvPr/>
         </p:nvSpPr>
@@ -6766,7 +6763,7 @@
       </p:sp>
       <p:sp>
         <p:nvSpPr>
-          <p:cNvPr id="9" name="t-60"/>
+          <p:cNvPr id="9" name="t-59"/>
           <p:cNvSpPr txBox="1"/>
           <p:nvPr/>
         </p:nvSpPr>
@@ -6802,7 +6799,7 @@
       </p:sp>
       <p:sp>
         <p:nvSpPr>
-          <p:cNvPr id="10" name="t-61"/>
+          <p:cNvPr id="10" name="t-60"/>
           <p:cNvSpPr txBox="1"/>
           <p:nvPr/>
         </p:nvSpPr>
@@ -6838,7 +6835,7 @@
       </p:sp>
       <p:sp>
         <p:nvSpPr>
-          <p:cNvPr id="11" name="icon-bg-62"/>
+          <p:cNvPr id="11" name="icon-bg-61"/>
           <p:cNvSpPr/>
           <p:nvPr/>
         </p:nvSpPr>
@@ -6863,7 +6860,7 @@
       </p:sp>
       <p:sp>
         <p:nvSpPr>
-          <p:cNvPr id="12" name="icon-62"/>
+          <p:cNvPr id="12" name="icon-61"/>
           <p:cNvSpPr txBox="1"/>
           <p:nvPr/>
         </p:nvSpPr>
@@ -6899,7 +6896,7 @@
       </p:sp>
       <p:sp>
         <p:nvSpPr>
-          <p:cNvPr id="13" name="t-63"/>
+          <p:cNvPr id="13" name="t-62"/>
           <p:cNvSpPr txBox="1"/>
           <p:nvPr/>
         </p:nvSpPr>
@@ -6935,7 +6932,7 @@
       </p:sp>
       <p:sp>
         <p:nvSpPr>
-          <p:cNvPr id="14" name="t-64"/>
+          <p:cNvPr id="14" name="t-63"/>
           <p:cNvSpPr txBox="1"/>
           <p:nvPr/>
         </p:nvSpPr>
@@ -6971,7 +6968,7 @@
       </p:sp>
       <p:sp>
         <p:nvSpPr>
-          <p:cNvPr id="15" name="icon-bg-65"/>
+          <p:cNvPr id="15" name="icon-bg-64"/>
           <p:cNvSpPr/>
           <p:nvPr/>
         </p:nvSpPr>
@@ -6996,7 +6993,7 @@
       </p:sp>
       <p:sp>
         <p:nvSpPr>
-          <p:cNvPr id="16" name="icon-65"/>
+          <p:cNvPr id="16" name="icon-64"/>
           <p:cNvSpPr txBox="1"/>
           <p:nvPr/>
         </p:nvSpPr>
@@ -7032,7 +7029,7 @@
       </p:sp>
       <p:sp>
         <p:nvSpPr>
-          <p:cNvPr id="17" name="t-66"/>
+          <p:cNvPr id="17" name="t-65"/>
           <p:cNvSpPr txBox="1"/>
           <p:nvPr/>
         </p:nvSpPr>
@@ -7068,7 +7065,7 @@
       </p:sp>
       <p:sp>
         <p:nvSpPr>
-          <p:cNvPr id="18" name="t-67"/>
+          <p:cNvPr id="18" name="t-66"/>
           <p:cNvSpPr txBox="1"/>
           <p:nvPr/>
         </p:nvSpPr>
@@ -7104,7 +7101,7 @@
       </p:sp>
       <p:sp>
         <p:nvSpPr>
-          <p:cNvPr id="19" name="icon-bg-68"/>
+          <p:cNvPr id="19" name="icon-bg-67"/>
           <p:cNvSpPr/>
           <p:nvPr/>
         </p:nvSpPr>
@@ -7129,7 +7126,7 @@
       </p:sp>
       <p:sp>
         <p:nvSpPr>
-          <p:cNvPr id="20" name="icon-68"/>
+          <p:cNvPr id="20" name="icon-67"/>
           <p:cNvSpPr txBox="1"/>
           <p:nvPr/>
         </p:nvSpPr>
@@ -7165,7 +7162,7 @@
       </p:sp>
       <p:sp>
         <p:nvSpPr>
-          <p:cNvPr id="21" name="t-69"/>
+          <p:cNvPr id="21" name="t-68"/>
           <p:cNvSpPr txBox="1"/>
           <p:nvPr/>
         </p:nvSpPr>
@@ -7201,7 +7198,7 @@
       </p:sp>
       <p:sp>
         <p:nvSpPr>
-          <p:cNvPr id="22" name="t-70"/>
+          <p:cNvPr id="22" name="t-69"/>
           <p:cNvSpPr txBox="1"/>
           <p:nvPr/>
         </p:nvSpPr>
@@ -8901,14 +8898,14 @@
       </p:sp>
       <p:sp>
         <p:nvSpPr>
-          <p:cNvPr id="3" name="ring-71"/>
+          <p:cNvPr id="3" name="ring-70"/>
           <p:cNvSpPr/>
           <p:nvPr/>
         </p:nvSpPr>
         <p:spPr>
           <a:xfrm>
-            <a:off x="365760" y="868680"/>
-            <a:ext cx="6035040" cy="6035040"/>
+            <a:off x="914400" y="1554480"/>
+            <a:ext cx="4937760" cy="4937760"/>
           </a:xfrm>
           <a:prstGeom prst="ellipse">
             <a:avLst/>
@@ -8926,14 +8923,14 @@
       </p:sp>
       <p:sp>
         <p:nvSpPr>
-          <p:cNvPr id="4" name="ring-72"/>
+          <p:cNvPr id="4" name="ring-71"/>
           <p:cNvSpPr/>
           <p:nvPr/>
         </p:nvSpPr>
         <p:spPr>
           <a:xfrm>
-            <a:off x="1097280" y="1600200"/>
-            <a:ext cx="4572000" cy="4572000"/>
+            <a:off x="1554480" y="2194560"/>
+            <a:ext cx="3657600" cy="3657600"/>
           </a:xfrm>
           <a:prstGeom prst="ellipse">
             <a:avLst/>
@@ -8951,14 +8948,14 @@
       </p:sp>
       <p:sp>
         <p:nvSpPr>
-          <p:cNvPr id="5" name="ring-73"/>
+          <p:cNvPr id="5" name="ring-72"/>
           <p:cNvSpPr/>
           <p:nvPr/>
         </p:nvSpPr>
         <p:spPr>
           <a:xfrm>
-            <a:off x="1828800" y="2331720"/>
-            <a:ext cx="3108960" cy="3108960"/>
+            <a:off x="2194560" y="2834640"/>
+            <a:ext cx="2377440" cy="2377440"/>
           </a:xfrm>
           <a:prstGeom prst="ellipse">
             <a:avLst/>
@@ -8976,13 +8973,13 @@
       </p:sp>
       <p:sp>
         <p:nvSpPr>
-          <p:cNvPr id="6" name="t-74"/>
+          <p:cNvPr id="6" name="t-73"/>
           <p:cNvSpPr txBox="1"/>
           <p:nvPr/>
         </p:nvSpPr>
         <p:spPr>
           <a:xfrm>
-            <a:off x="2011680" y="3657600"/>
+            <a:off x="2011680" y="3794760"/>
             <a:ext cx="2743200" cy="457200"/>
           </a:xfrm>
           <a:prstGeom prst="rect">
@@ -9012,13 +9009,13 @@
       </p:sp>
       <p:sp>
         <p:nvSpPr>
-          <p:cNvPr id="7" name="t-75"/>
+          <p:cNvPr id="7" name="t-74"/>
           <p:cNvSpPr txBox="1"/>
           <p:nvPr/>
         </p:nvSpPr>
         <p:spPr>
           <a:xfrm>
-            <a:off x="2011680" y="1965960"/>
+            <a:off x="2011680" y="2468880"/>
             <a:ext cx="2743200" cy="365760"/>
           </a:xfrm>
           <a:prstGeom prst="rect">
@@ -9048,13 +9045,13 @@
       </p:sp>
       <p:sp>
         <p:nvSpPr>
-          <p:cNvPr id="8" name="t-76"/>
+          <p:cNvPr id="8" name="t-75"/>
           <p:cNvSpPr txBox="1"/>
           <p:nvPr/>
         </p:nvSpPr>
         <p:spPr>
           <a:xfrm>
-            <a:off x="2011680" y="1143000"/>
+            <a:off x="2011680" y="1828800"/>
             <a:ext cx="2743200" cy="365760"/>
           </a:xfrm>
           <a:prstGeom prst="rect">
@@ -9084,7 +9081,7 @@
       </p:sp>
       <p:sp>
         <p:nvSpPr>
-          <p:cNvPr id="9" name="t-77"/>
+          <p:cNvPr id="9" name="t-76"/>
           <p:cNvSpPr txBox="1"/>
           <p:nvPr/>
         </p:nvSpPr>
@@ -9120,7 +9117,7 @@
       </p:sp>
       <p:sp>
         <p:nvSpPr>
-          <p:cNvPr id="10" name="t-78"/>
+          <p:cNvPr id="10" name="t-77"/>
           <p:cNvSpPr txBox="1"/>
           <p:nvPr/>
         </p:nvSpPr>
@@ -9156,7 +9153,7 @@
       </p:sp>
       <p:sp>
         <p:nvSpPr>
-          <p:cNvPr id="11" name="t-79"/>
+          <p:cNvPr id="11" name="t-78"/>
           <p:cNvSpPr txBox="1"/>
           <p:nvPr/>
         </p:nvSpPr>
@@ -9192,7 +9189,7 @@
       </p:sp>
       <p:sp>
         <p:nvSpPr>
-          <p:cNvPr id="12" name="t-80"/>
+          <p:cNvPr id="12" name="t-79"/>
           <p:cNvSpPr txBox="1"/>
           <p:nvPr/>
         </p:nvSpPr>
@@ -9228,7 +9225,7 @@
       </p:sp>
       <p:sp>
         <p:nvSpPr>
-          <p:cNvPr id="13" name="t-81"/>
+          <p:cNvPr id="13" name="t-80"/>
           <p:cNvSpPr txBox="1"/>
           <p:nvPr/>
         </p:nvSpPr>
@@ -9264,7 +9261,7 @@
       </p:sp>
       <p:sp>
         <p:nvSpPr>
-          <p:cNvPr id="14" name="t-82"/>
+          <p:cNvPr id="14" name="t-81"/>
           <p:cNvSpPr txBox="1"/>
           <p:nvPr/>
         </p:nvSpPr>
@@ -9408,7 +9405,7 @@
       </p:sp>
       <p:sp>
         <p:nvSpPr>
-          <p:cNvPr id="3" name="card-83"/>
+          <p:cNvPr id="3" name="card-82"/>
           <p:cNvSpPr/>
           <p:nvPr/>
         </p:nvSpPr>
@@ -9435,7 +9432,7 @@
       </p:sp>
       <p:sp>
         <p:nvSpPr>
-          <p:cNvPr id="4" name="t-84"/>
+          <p:cNvPr id="4" name="t-83"/>
           <p:cNvSpPr txBox="1"/>
           <p:nvPr/>
         </p:nvSpPr>
@@ -9471,7 +9468,7 @@
       </p:sp>
       <p:sp>
         <p:nvSpPr>
-          <p:cNvPr id="5" name="t-85"/>
+          <p:cNvPr id="5" name="t-84"/>
           <p:cNvSpPr txBox="1"/>
           <p:nvPr/>
         </p:nvSpPr>
@@ -9583,7 +9580,7 @@
       </p:sp>
       <p:sp>
         <p:nvSpPr>
-          <p:cNvPr id="7" name="card-86"/>
+          <p:cNvPr id="7" name="card-85"/>
           <p:cNvSpPr/>
           <p:nvPr/>
         </p:nvSpPr>
@@ -9610,7 +9607,7 @@
       </p:sp>
       <p:sp>
         <p:nvSpPr>
-          <p:cNvPr id="8" name="t-87"/>
+          <p:cNvPr id="8" name="t-86"/>
           <p:cNvSpPr txBox="1"/>
           <p:nvPr/>
         </p:nvSpPr>
@@ -9646,7 +9643,7 @@
       </p:sp>
       <p:sp>
         <p:nvSpPr>
-          <p:cNvPr id="9" name="t-88"/>
+          <p:cNvPr id="9" name="t-87"/>
           <p:cNvSpPr txBox="1"/>
           <p:nvPr/>
         </p:nvSpPr>
@@ -9758,7 +9755,7 @@
       </p:sp>
       <p:sp>
         <p:nvSpPr>
-          <p:cNvPr id="11" name="card-89"/>
+          <p:cNvPr id="11" name="card-88"/>
           <p:cNvSpPr/>
           <p:nvPr/>
         </p:nvSpPr>
@@ -9785,7 +9782,7 @@
       </p:sp>
       <p:sp>
         <p:nvSpPr>
-          <p:cNvPr id="12" name="t-90"/>
+          <p:cNvPr id="12" name="t-89"/>
           <p:cNvSpPr txBox="1"/>
           <p:nvPr/>
         </p:nvSpPr>
@@ -9821,7 +9818,7 @@
       </p:sp>
       <p:sp>
         <p:nvSpPr>
-          <p:cNvPr id="13" name="t-91"/>
+          <p:cNvPr id="13" name="t-90"/>
           <p:cNvSpPr txBox="1"/>
           <p:nvPr/>
         </p:nvSpPr>

</xml_diff>